<commit_message>
Updated project and presentation
</commit_message>
<xml_diff>
--- a/Blood_Banking_System_Project.pptx
+++ b/Blood_Banking_System_Project.pptx
@@ -5,20 +5,21 @@
     <p:sldMasterId id="2147484159" r:id="rId1"/>
   </p:sldMasterIdLst>
   <p:sldIdLst>
-    <p:sldId id="256" r:id="rId2"/>
-    <p:sldId id="257" r:id="rId3"/>
-    <p:sldId id="258" r:id="rId4"/>
-    <p:sldId id="259" r:id="rId5"/>
-    <p:sldId id="260" r:id="rId6"/>
-    <p:sldId id="261" r:id="rId7"/>
-    <p:sldId id="262" r:id="rId8"/>
-    <p:sldId id="263" r:id="rId9"/>
-    <p:sldId id="264" r:id="rId10"/>
-    <p:sldId id="265" r:id="rId11"/>
-    <p:sldId id="266" r:id="rId12"/>
-    <p:sldId id="267" r:id="rId13"/>
-    <p:sldId id="268" r:id="rId14"/>
-    <p:sldId id="269" r:id="rId15"/>
+    <p:sldId id="271" r:id="rId2"/>
+    <p:sldId id="256" r:id="rId3"/>
+    <p:sldId id="257" r:id="rId4"/>
+    <p:sldId id="258" r:id="rId5"/>
+    <p:sldId id="259" r:id="rId6"/>
+    <p:sldId id="260" r:id="rId7"/>
+    <p:sldId id="261" r:id="rId8"/>
+    <p:sldId id="262" r:id="rId9"/>
+    <p:sldId id="263" r:id="rId10"/>
+    <p:sldId id="264" r:id="rId11"/>
+    <p:sldId id="265" r:id="rId12"/>
+    <p:sldId id="266" r:id="rId13"/>
+    <p:sldId id="267" r:id="rId14"/>
+    <p:sldId id="268" r:id="rId15"/>
+    <p:sldId id="269" r:id="rId16"/>
   </p:sldIdLst>
   <p:sldSz cx="12192000" cy="6858000"/>
   <p:notesSz cx="6858000" cy="9144000"/>
@@ -354,7 +355,7 @@
           <a:p>
             <a:fld id="{5BCAD085-E8A6-8845-BD4E-CB4CCA059FC4}" type="datetimeFigureOut">
               <a:rPr lang="en-US" smtClean="0"/>
-              <a:t>9/25/2026</a:t>
+              <a:t>9/26/2026</a:t>
             </a:fld>
             <a:endParaRPr lang="en-US"/>
           </a:p>
@@ -533,7 +534,7 @@
           <a:p>
             <a:fld id="{5BCAD085-E8A6-8845-BD4E-CB4CCA059FC4}" type="datetimeFigureOut">
               <a:rPr lang="en-US" smtClean="0"/>
-              <a:t>9/25/2026</a:t>
+              <a:t>9/26/2026</a:t>
             </a:fld>
             <a:endParaRPr lang="en-US"/>
           </a:p>
@@ -826,7 +827,7 @@
           <a:p>
             <a:fld id="{5BCAD085-E8A6-8845-BD4E-CB4CCA059FC4}" type="datetimeFigureOut">
               <a:rPr lang="en-US" smtClean="0"/>
-              <a:t>9/25/2026</a:t>
+              <a:t>9/26/2026</a:t>
             </a:fld>
             <a:endParaRPr lang="en-US"/>
           </a:p>
@@ -1188,7 +1189,7 @@
           <a:p>
             <a:fld id="{5BCAD085-E8A6-8845-BD4E-CB4CCA059FC4}" type="datetimeFigureOut">
               <a:rPr lang="en-US" smtClean="0"/>
-              <a:t>9/25/2026</a:t>
+              <a:t>9/26/2026</a:t>
             </a:fld>
             <a:endParaRPr lang="en-US"/>
           </a:p>
@@ -1431,7 +1432,7 @@
           <a:p>
             <a:fld id="{5BCAD085-E8A6-8845-BD4E-CB4CCA059FC4}" type="datetimeFigureOut">
               <a:rPr lang="en-US" smtClean="0"/>
-              <a:t>9/25/2026</a:t>
+              <a:t>9/26/2026</a:t>
             </a:fld>
             <a:endParaRPr lang="en-US"/>
           </a:p>
@@ -1707,7 +1708,7 @@
           <a:p>
             <a:fld id="{5BCAD085-E8A6-8845-BD4E-CB4CCA059FC4}" type="datetimeFigureOut">
               <a:rPr lang="en-US" smtClean="0"/>
-              <a:t>9/25/2026</a:t>
+              <a:t>9/26/2026</a:t>
             </a:fld>
             <a:endParaRPr lang="en-US"/>
           </a:p>
@@ -2111,7 +2112,7 @@
           <a:p>
             <a:fld id="{5BCAD085-E8A6-8845-BD4E-CB4CCA059FC4}" type="datetimeFigureOut">
               <a:rPr lang="en-US" smtClean="0"/>
-              <a:t>9/25/2026</a:t>
+              <a:t>9/26/2026</a:t>
             </a:fld>
             <a:endParaRPr lang="en-US"/>
           </a:p>
@@ -2367,7 +2368,7 @@
           <a:p>
             <a:fld id="{5BCAD085-E8A6-8845-BD4E-CB4CCA059FC4}" type="datetimeFigureOut">
               <a:rPr lang="en-US" smtClean="0"/>
-              <a:t>9/25/2026</a:t>
+              <a:t>9/26/2026</a:t>
             </a:fld>
             <a:endParaRPr lang="en-US"/>
           </a:p>
@@ -2705,7 +2706,7 @@
           <a:p>
             <a:fld id="{5BCAD085-E8A6-8845-BD4E-CB4CCA059FC4}" type="datetimeFigureOut">
               <a:rPr lang="en-US" smtClean="0"/>
-              <a:t>9/25/2026</a:t>
+              <a:t>9/26/2026</a:t>
             </a:fld>
             <a:endParaRPr lang="en-US"/>
           </a:p>
@@ -2925,7 +2926,7 @@
           <a:p>
             <a:fld id="{5BCAD085-E8A6-8845-BD4E-CB4CCA059FC4}" type="datetimeFigureOut">
               <a:rPr lang="en-US" smtClean="0"/>
-              <a:t>9/25/2026</a:t>
+              <a:t>9/26/2026</a:t>
             </a:fld>
             <a:endParaRPr lang="en-US"/>
           </a:p>
@@ -3249,7 +3250,7 @@
           <a:p>
             <a:fld id="{5BCAD085-E8A6-8845-BD4E-CB4CCA059FC4}" type="datetimeFigureOut">
               <a:rPr lang="en-US" smtClean="0"/>
-              <a:t>9/25/2026</a:t>
+              <a:t>9/26/2026</a:t>
             </a:fld>
             <a:endParaRPr lang="en-US"/>
           </a:p>
@@ -3470,7 +3471,7 @@
           <a:p>
             <a:fld id="{5BCAD085-E8A6-8845-BD4E-CB4CCA059FC4}" type="datetimeFigureOut">
               <a:rPr lang="en-US" smtClean="0"/>
-              <a:t>9/25/2026</a:t>
+              <a:t>9/26/2026</a:t>
             </a:fld>
             <a:endParaRPr lang="en-US"/>
           </a:p>
@@ -3778,7 +3779,7 @@
           <a:p>
             <a:fld id="{5BCAD085-E8A6-8845-BD4E-CB4CCA059FC4}" type="datetimeFigureOut">
               <a:rPr lang="en-US" smtClean="0"/>
-              <a:t>9/25/2026</a:t>
+              <a:t>9/26/2026</a:t>
             </a:fld>
             <a:endParaRPr lang="en-US"/>
           </a:p>
@@ -4118,7 +4119,7 @@
           <a:p>
             <a:fld id="{5BCAD085-E8A6-8845-BD4E-CB4CCA059FC4}" type="datetimeFigureOut">
               <a:rPr lang="en-US" smtClean="0"/>
-              <a:t>9/25/2026</a:t>
+              <a:t>9/26/2026</a:t>
             </a:fld>
             <a:endParaRPr lang="en-US"/>
           </a:p>
@@ -4349,7 +4350,7 @@
           <a:p>
             <a:fld id="{5BCAD085-E8A6-8845-BD4E-CB4CCA059FC4}" type="datetimeFigureOut">
               <a:rPr lang="en-US" smtClean="0"/>
-              <a:t>9/25/2026</a:t>
+              <a:t>9/26/2026</a:t>
             </a:fld>
             <a:endParaRPr lang="en-US"/>
           </a:p>
@@ -4729,7 +4730,7 @@
           <a:p>
             <a:fld id="{5BCAD085-E8A6-8845-BD4E-CB4CCA059FC4}" type="datetimeFigureOut">
               <a:rPr lang="en-US" smtClean="0"/>
-              <a:t>9/25/2026</a:t>
+              <a:t>9/26/2026</a:t>
             </a:fld>
             <a:endParaRPr lang="en-US"/>
           </a:p>
@@ -5265,7 +5266,7 @@
           <a:p>
             <a:fld id="{5BCAD085-E8A6-8845-BD4E-CB4CCA059FC4}" type="datetimeFigureOut">
               <a:rPr lang="en-US" smtClean="0"/>
-              <a:t>9/25/2026</a:t>
+              <a:t>9/26/2026</a:t>
             </a:fld>
             <a:endParaRPr lang="en-US"/>
           </a:p>
@@ -5402,7 +5403,7 @@
           <a:p>
             <a:fld id="{5BCAD085-E8A6-8845-BD4E-CB4CCA059FC4}" type="datetimeFigureOut">
               <a:rPr lang="en-US" smtClean="0"/>
-              <a:t>9/25/2026</a:t>
+              <a:t>9/26/2026</a:t>
             </a:fld>
             <a:endParaRPr lang="en-US"/>
           </a:p>
@@ -5619,7 +5620,7 @@
           <a:p>
             <a:fld id="{5BCAD085-E8A6-8845-BD4E-CB4CCA059FC4}" type="datetimeFigureOut">
               <a:rPr lang="en-US" smtClean="0"/>
-              <a:t>9/25/2026</a:t>
+              <a:t>9/26/2026</a:t>
             </a:fld>
             <a:endParaRPr lang="en-US"/>
           </a:p>
@@ -5935,7 +5936,7 @@
           <a:p>
             <a:fld id="{5BCAD085-E8A6-8845-BD4E-CB4CCA059FC4}" type="datetimeFigureOut">
               <a:rPr lang="en-US" smtClean="0"/>
-              <a:t>9/25/2026</a:t>
+              <a:t>9/26/2026</a:t>
             </a:fld>
             <a:endParaRPr lang="en-US"/>
           </a:p>
@@ -6301,7 +6302,7 @@
           <a:p>
             <a:fld id="{5BCAD085-E8A6-8845-BD4E-CB4CCA059FC4}" type="datetimeFigureOut">
               <a:rPr lang="en-US" smtClean="0"/>
-              <a:t>9/25/2026</a:t>
+              <a:t>9/26/2026</a:t>
             </a:fld>
             <a:endParaRPr lang="en-US"/>
           </a:p>
@@ -6611,7 +6612,7 @@
             <a:fld id="{2ABAD28B-DD56-4B56-883A-96608C765E28}" type="datetimeFigureOut">
               <a:rPr lang="en-US" smtClean="0"/>
               <a:pPr/>
-              <a:t>9/25/2026</a:t>
+              <a:t>9/26/2026</a:t>
             </a:fld>
             <a:endParaRPr lang="en-US" dirty="0"/>
           </a:p>
@@ -6854,7 +6855,7 @@
             <a:fld id="{2ABAD28B-DD56-4B56-883A-96608C765E28}" type="datetimeFigureOut">
               <a:rPr lang="en-US" smtClean="0"/>
               <a:pPr/>
-              <a:t>9/25/2026</a:t>
+              <a:t>9/26/2026</a:t>
             </a:fld>
             <a:endParaRPr lang="en-US" dirty="0"/>
           </a:p>
@@ -7087,7 +7088,7 @@
           <a:p>
             <a:fld id="{5BCAD085-E8A6-8845-BD4E-CB4CCA059FC4}" type="datetimeFigureOut">
               <a:rPr lang="en-US" smtClean="0"/>
-              <a:t>9/25/2026</a:t>
+              <a:t>9/26/2026</a:t>
             </a:fld>
             <a:endParaRPr lang="en-US"/>
           </a:p>
@@ -7475,7 +7476,7 @@
           <a:p>
             <a:fld id="{5BCAD085-E8A6-8845-BD4E-CB4CCA059FC4}" type="datetimeFigureOut">
               <a:rPr lang="en-US" smtClean="0"/>
-              <a:t>9/25/2026</a:t>
+              <a:t>9/26/2026</a:t>
             </a:fld>
             <a:endParaRPr lang="en-US"/>
           </a:p>
@@ -7832,7 +7833,7 @@
           <a:p>
             <a:fld id="{5BCAD085-E8A6-8845-BD4E-CB4CCA059FC4}" type="datetimeFigureOut">
               <a:rPr lang="en-US" smtClean="0"/>
-              <a:t>9/25/2026</a:t>
+              <a:t>9/26/2026</a:t>
             </a:fld>
             <a:endParaRPr lang="en-US"/>
           </a:p>
@@ -8162,7 +8163,7 @@
           <a:p>
             <a:fld id="{5BCAD085-E8A6-8845-BD4E-CB4CCA059FC4}" type="datetimeFigureOut">
               <a:rPr lang="en-US" smtClean="0"/>
-              <a:t>9/25/2026</a:t>
+              <a:t>9/26/2026</a:t>
             </a:fld>
             <a:endParaRPr lang="en-US"/>
           </a:p>
@@ -8540,7 +8541,7 @@
           <a:p>
             <a:fld id="{5BCAD085-E8A6-8845-BD4E-CB4CCA059FC4}" type="datetimeFigureOut">
               <a:rPr lang="en-US" smtClean="0"/>
-              <a:t>9/25/2026</a:t>
+              <a:t>9/26/2026</a:t>
             </a:fld>
             <a:endParaRPr lang="en-US"/>
           </a:p>
@@ -9016,145 +9017,117 @@
       </p:grpSpPr>
       <p:sp>
         <p:nvSpPr>
-          <p:cNvPr id="2" name="TextBox 1"/>
-          <p:cNvSpPr txBox="1"/>
-          <p:nvPr/>
-        </p:nvSpPr>
-        <p:spPr>
-          <a:xfrm>
-            <a:off x="640080" y="411480"/>
-            <a:ext cx="10972800" cy="731520"/>
-          </a:xfrm>
-          <a:prstGeom prst="rect">
-            <a:avLst/>
-          </a:prstGeom>
-          <a:noFill/>
-        </p:spPr>
-        <p:txBody>
-          <a:bodyPr wrap="none">
-            <a:spAutoFit/>
+          <p:cNvPr id="2" name="Title 1">
+            <a:extLst>
+              <a:ext uri="{FF2B5EF4-FFF2-40B4-BE49-F238E27FC236}">
+                <a16:creationId xmlns:a16="http://schemas.microsoft.com/office/drawing/2014/main" id="{61843549-BCE9-1693-9424-45F01BF9D245}"/>
+              </a:ext>
+            </a:extLst>
+          </p:cNvPr>
+          <p:cNvSpPr>
+            <a:spLocks noGrp="1"/>
+          </p:cNvSpPr>
+          <p:nvPr>
+            <p:ph type="title"/>
+          </p:nvPr>
+        </p:nvSpPr>
+        <p:spPr>
+          <a:xfrm>
+            <a:off x="420791" y="285136"/>
+            <a:ext cx="8380309" cy="668593"/>
+          </a:xfrm>
+        </p:spPr>
+        <p:txBody>
+          <a:bodyPr>
+            <a:normAutofit fontScale="90000"/>
           </a:bodyPr>
           <a:lstStyle/>
           <a:p>
-            <a:pPr>
-              <a:defRPr sz="3000" b="1">
-                <a:solidFill>
-                  <a:srgbClr val="B30000"/>
-                </a:solidFill>
-              </a:defRPr>
-            </a:pPr>
-            <a:r>
+            <a:r>
+              <a:rPr lang="en-US" sz="4900" dirty="0">
+                <a:solidFill>
+                  <a:srgbClr val="FF0000"/>
+                </a:solidFill>
+              </a:rPr>
               <a:t>BLOOD BANKING SYSTEM</a:t>
             </a:r>
-          </a:p>
-        </p:txBody>
-      </p:sp>
-      <p:sp>
-        <p:nvSpPr>
-          <p:cNvPr id="3" name="TextBox 2"/>
-          <p:cNvSpPr txBox="1"/>
-          <p:nvPr/>
-        </p:nvSpPr>
-        <p:spPr>
-          <a:xfrm>
-            <a:off x="822960" y="1371600"/>
-            <a:ext cx="10607040" cy="2503249"/>
-          </a:xfrm>
-          <a:prstGeom prst="rect">
-            <a:avLst/>
-          </a:prstGeom>
-          <a:noFill/>
-        </p:spPr>
-        <p:txBody>
-          <a:bodyPr wrap="square">
-            <a:spAutoFit/>
-          </a:bodyPr>
-          <a:lstStyle/>
-          <a:p>
-            <a:pPr>
-              <a:spcAft>
-                <a:spcPts val="1400"/>
-              </a:spcAft>
-              <a:defRPr sz="2200">
-                <a:solidFill>
-                  <a:srgbClr val="323232"/>
-                </a:solidFill>
-              </a:defRPr>
-            </a:pPr>
-            <a:r>
-              <a:rPr dirty="0"/>
-              <a:t>A simple web-based Blood Banking System</a:t>
-            </a:r>
-          </a:p>
-          <a:p>
-            <a:pPr>
-              <a:spcAft>
-                <a:spcPts val="1400"/>
-              </a:spcAft>
-              <a:defRPr sz="2200">
-                <a:solidFill>
-                  <a:srgbClr val="323232"/>
-                </a:solidFill>
-              </a:defRPr>
-            </a:pPr>
-            <a:r>
-              <a:rPr dirty="0"/>
-              <a:t>Front End Development Frameworks Project</a:t>
-            </a:r>
-          </a:p>
-          <a:p>
-            <a:pPr>
-              <a:spcAft>
-                <a:spcPts val="1400"/>
-              </a:spcAft>
-              <a:defRPr sz="2200">
-                <a:solidFill>
-                  <a:srgbClr val="323232"/>
-                </a:solidFill>
-              </a:defRPr>
-            </a:pPr>
-            <a:r>
-              <a:rPr dirty="0"/>
-              <a:t>Donor Registration </a:t>
-            </a:r>
-            <a:endParaRPr lang="en-US" dirty="0"/>
-          </a:p>
-          <a:p>
-            <a:pPr>
-              <a:spcAft>
-                <a:spcPts val="1400"/>
-              </a:spcAft>
-              <a:defRPr sz="2200">
-                <a:solidFill>
-                  <a:srgbClr val="323232"/>
-                </a:solidFill>
-              </a:defRPr>
-            </a:pPr>
-            <a:r>
-              <a:rPr dirty="0"/>
-              <a:t>• Blood Requests </a:t>
-            </a:r>
-            <a:endParaRPr lang="en-US" dirty="0"/>
-          </a:p>
-          <a:p>
-            <a:pPr>
-              <a:spcAft>
-                <a:spcPts val="1400"/>
-              </a:spcAft>
-              <a:defRPr sz="2200">
-                <a:solidFill>
-                  <a:srgbClr val="323232"/>
-                </a:solidFill>
-              </a:defRPr>
-            </a:pPr>
-            <a:r>
-              <a:rPr dirty="0"/>
-              <a:t>• Inventory Management</a:t>
+            <a:r>
+              <a:rPr lang="en-US" dirty="0"/>
+              <a:t> </a:t>
+            </a:r>
+            <a:r>
+              <a:rPr lang="en-US" sz="5300" dirty="0"/>
+              <a:t>🩸</a:t>
+            </a:r>
+            <a:br>
+              <a:rPr lang="en-US" sz="5300" dirty="0"/>
+            </a:br>
+            <a:br>
+              <a:rPr lang="en-US" sz="5300" dirty="0"/>
+            </a:br>
+            <a:r>
+              <a:rPr lang="en-US" dirty="0"/>
+              <a:t>A Web-Based Blood Donation &amp; Management System</a:t>
+            </a:r>
+            <a:br>
+              <a:rPr lang="en-US" dirty="0"/>
+            </a:br>
+            <a:br>
+              <a:rPr lang="en-US" dirty="0"/>
+            </a:br>
+            <a:r>
+              <a:rPr lang="en-US" b="1" dirty="0"/>
+              <a:t>PROJECT TEAM</a:t>
+            </a:r>
+            <a:br>
+              <a:rPr lang="en-US" dirty="0"/>
+            </a:br>
+            <a:r>
+              <a:rPr lang="en-US" dirty="0"/>
+              <a:t>👤 Karthik Kothakota — 2500030930</a:t>
+            </a:r>
+            <a:br>
+              <a:rPr lang="en-US" dirty="0"/>
+            </a:br>
+            <a:r>
+              <a:rPr lang="en-US" dirty="0"/>
+              <a:t>👤 Morla Srishanth — 2500030125</a:t>
+            </a:r>
+            <a:br>
+              <a:rPr lang="en-US" dirty="0"/>
+            </a:br>
+            <a:r>
+              <a:rPr lang="en-US" dirty="0"/>
+              <a:t>👤 T. Tejaswini — 2500031121</a:t>
+            </a:r>
+            <a:br>
+              <a:rPr lang="en-US" dirty="0"/>
+            </a:br>
+            <a:br>
+              <a:rPr lang="en-US" dirty="0"/>
+            </a:br>
+            <a:br>
+              <a:rPr lang="en-US" dirty="0"/>
+            </a:br>
+            <a:br>
+              <a:rPr lang="en-US" dirty="0"/>
+            </a:br>
+            <a:br>
+              <a:rPr lang="en-US" dirty="0"/>
+            </a:br>
+            <a:r>
+              <a:rPr lang="en-US" dirty="0"/>
+              <a:t>Front End Development Frameworks</a:t>
             </a:r>
           </a:p>
         </p:txBody>
       </p:sp>
     </p:spTree>
+    <p:extLst>
+      <p:ext uri="{BB962C8B-B14F-4D97-AF65-F5344CB8AC3E}">
+        <p14:creationId xmlns:p14="http://schemas.microsoft.com/office/powerpoint/2010/main" val="2970502186"/>
+      </p:ext>
+    </p:extLst>
   </p:cSld>
   <p:clrMapOvr>
     <a:masterClrMapping/>
@@ -9209,7 +9182,7 @@
               </a:defRPr>
             </a:pPr>
             <a:r>
-              <a:t>SYSTEM WORKFLOW</a:t>
+              <a:t>BLOOD INVENTORY</a:t>
             </a:r>
           </a:p>
         </p:txBody>
@@ -9247,7 +9220,7 @@
               </a:defRPr>
             </a:pPr>
             <a:r>
-              <a:t>Login → Choose Donor / Receiver</a:t>
+              <a:t>Displays all 8 blood groups:</a:t>
             </a:r>
           </a:p>
           <a:p>
@@ -9262,7 +9235,7 @@
               </a:defRPr>
             </a:pPr>
             <a:r>
-              <a:t>Donor → Register Details → Add Blood Unit → Inventory</a:t>
+              <a:t>A+, A-, B+, B-, AB+, AB-, O+, O-</a:t>
             </a:r>
           </a:p>
           <a:p>
@@ -9277,7 +9250,7 @@
               </a:defRPr>
             </a:pPr>
             <a:r>
-              <a:t>Receiver → Request Blood → Check Inventory → Deduct Units → Inventory</a:t>
+              <a:t>Inventory starts from 0.</a:t>
             </a:r>
           </a:p>
           <a:p>
@@ -9292,7 +9265,7 @@
               </a:defRPr>
             </a:pPr>
             <a:r>
-              <a:t>Future enhancement: match donor and receiver by blood group + state + city.</a:t>
+              <a:t>Values are updated automatically using donor registrations and blood requests.</a:t>
             </a:r>
           </a:p>
         </p:txBody>
@@ -9352,7 +9325,7 @@
               </a:defRPr>
             </a:pPr>
             <a:r>
-              <a:t>ADVANTAGES</a:t>
+              <a:t>SYSTEM WORKFLOW</a:t>
             </a:r>
           </a:p>
         </p:txBody>
@@ -9383,14 +9356,14 @@
               <a:spcAft>
                 <a:spcPts val="1400"/>
               </a:spcAft>
-              <a:defRPr sz="1900">
+              <a:defRPr sz="2200">
                 <a:solidFill>
                   <a:srgbClr val="323232"/>
                 </a:solidFill>
               </a:defRPr>
             </a:pPr>
             <a:r>
-              <a:t>Simple and easy-to-use interface.</a:t>
+              <a:t>Login → Choose Donor / Receiver</a:t>
             </a:r>
           </a:p>
           <a:p>
@@ -9398,14 +9371,14 @@
               <a:spcAft>
                 <a:spcPts val="1400"/>
               </a:spcAft>
-              <a:defRPr sz="1900">
+              <a:defRPr sz="2200">
                 <a:solidFill>
                   <a:srgbClr val="323232"/>
                 </a:solidFill>
               </a:defRPr>
             </a:pPr>
             <a:r>
-              <a:t>Reduces manual record keeping.</a:t>
+              <a:t>Donor → Register Details → Add Blood Unit → Inventory</a:t>
             </a:r>
           </a:p>
           <a:p>
@@ -9413,14 +9386,14 @@
               <a:spcAft>
                 <a:spcPts val="1400"/>
               </a:spcAft>
-              <a:defRPr sz="1900">
+              <a:defRPr sz="2200">
                 <a:solidFill>
                   <a:srgbClr val="323232"/>
                 </a:solidFill>
               </a:defRPr>
             </a:pPr>
             <a:r>
-              <a:t>Provides quick inventory information.</a:t>
+              <a:t>Receiver → Request Blood → Check Inventory → Deduct Units → Inventory</a:t>
             </a:r>
           </a:p>
           <a:p>
@@ -9428,29 +9401,14 @@
               <a:spcAft>
                 <a:spcPts val="1400"/>
               </a:spcAft>
-              <a:defRPr sz="1900">
+              <a:defRPr sz="2200">
                 <a:solidFill>
                   <a:srgbClr val="323232"/>
                 </a:solidFill>
               </a:defRPr>
             </a:pPr>
             <a:r>
-              <a:t>Automatically updates blood availability.</a:t>
-            </a:r>
-          </a:p>
-          <a:p>
-            <a:pPr>
-              <a:spcAft>
-                <a:spcPts val="1400"/>
-              </a:spcAft>
-              <a:defRPr sz="1900">
-                <a:solidFill>
-                  <a:srgbClr val="323232"/>
-                </a:solidFill>
-              </a:defRPr>
-            </a:pPr>
-            <a:r>
-              <a:t>Can be expanded with a database and real-time communication.</a:t>
+              <a:t>Future enhancement: match donor and receiver by blood group + state + city.</a:t>
             </a:r>
           </a:p>
         </p:txBody>
@@ -9510,7 +9468,7 @@
               </a:defRPr>
             </a:pPr>
             <a:r>
-              <a:t>FUTURE ENHANCEMENTS</a:t>
+              <a:t>ADVANTAGES</a:t>
             </a:r>
           </a:p>
         </p:txBody>
@@ -9524,7 +9482,7 @@
         <p:spPr>
           <a:xfrm>
             <a:off x="822960" y="1371600"/>
-            <a:ext cx="10607040" cy="4754880"/>
+            <a:ext cx="10607040" cy="2272417"/>
           </a:xfrm>
           <a:prstGeom prst="rect">
             <a:avLst/>
@@ -9548,7 +9506,8 @@
               </a:defRPr>
             </a:pPr>
             <a:r>
-              <a:t>Database integration.</a:t>
+              <a:rPr dirty="0"/>
+              <a:t>Simple and easy-to-use interface.</a:t>
             </a:r>
           </a:p>
           <a:p>
@@ -9563,7 +9522,8 @@
               </a:defRPr>
             </a:pPr>
             <a:r>
-              <a:t>Donor and receiver matching by blood group, state and city.</a:t>
+              <a:rPr dirty="0"/>
+              <a:t>Reduces manual record keeping.</a:t>
             </a:r>
           </a:p>
           <a:p>
@@ -9578,7 +9538,8 @@
               </a:defRPr>
             </a:pPr>
             <a:r>
-              <a:t>Admin dashboard.</a:t>
+              <a:rPr dirty="0"/>
+              <a:t>Provides quick inventory information.</a:t>
             </a:r>
           </a:p>
           <a:p>
@@ -9593,7 +9554,8 @@
               </a:defRPr>
             </a:pPr>
             <a:r>
-              <a:t>Real-time notifications.</a:t>
+              <a:rPr dirty="0"/>
+              <a:t>Automatically updates blood availability.</a:t>
             </a:r>
           </a:p>
           <a:p>
@@ -9608,22 +9570,8 @@
               </a:defRPr>
             </a:pPr>
             <a:r>
-              <a:t>Hospital and blood-bank accounts.</a:t>
-            </a:r>
-          </a:p>
-          <a:p>
-            <a:pPr>
-              <a:spcAft>
-                <a:spcPts val="1400"/>
-              </a:spcAft>
-              <a:defRPr sz="1900">
-                <a:solidFill>
-                  <a:srgbClr val="323232"/>
-                </a:solidFill>
-              </a:defRPr>
-            </a:pPr>
-            <a:r>
-              <a:t>Secure user authentication.</a:t>
+              <a:rPr dirty="0"/>
+              <a:t>Can be expanded with a database and real-time communication.</a:t>
             </a:r>
           </a:p>
         </p:txBody>
@@ -9683,7 +9631,7 @@
               </a:defRPr>
             </a:pPr>
             <a:r>
-              <a:t>CONCLUSION</a:t>
+              <a:t>FUTURE ENHANCEMENTS</a:t>
             </a:r>
           </a:p>
         </p:txBody>
@@ -9714,14 +9662,14 @@
               <a:spcAft>
                 <a:spcPts val="1400"/>
               </a:spcAft>
-              <a:defRPr sz="2200">
+              <a:defRPr sz="1900">
                 <a:solidFill>
                   <a:srgbClr val="323232"/>
                 </a:solidFill>
               </a:defRPr>
             </a:pPr>
             <a:r>
-              <a:t>The Blood Banking System provides a simple way to manage blood donors, requests and inventory.</a:t>
+              <a:t>Database integration.</a:t>
             </a:r>
           </a:p>
           <a:p>
@@ -9729,14 +9677,14 @@
               <a:spcAft>
                 <a:spcPts val="1400"/>
               </a:spcAft>
-              <a:defRPr sz="2200">
+              <a:defRPr sz="1900">
                 <a:solidFill>
                   <a:srgbClr val="323232"/>
                 </a:solidFill>
               </a:defRPr>
             </a:pPr>
             <a:r>
-              <a:t>HTML, CSS and JavaScript are used to build the system.</a:t>
+              <a:t>Donor and receiver matching by blood group, state and city.</a:t>
             </a:r>
           </a:p>
           <a:p>
@@ -9744,14 +9692,59 @@
               <a:spcAft>
                 <a:spcPts val="1400"/>
               </a:spcAft>
-              <a:defRPr sz="2200">
+              <a:defRPr sz="1900">
                 <a:solidFill>
                   <a:srgbClr val="323232"/>
                 </a:solidFill>
               </a:defRPr>
             </a:pPr>
             <a:r>
-              <a:t>The project demonstrates how a basic web application can support blood availability management.</a:t>
+              <a:t>Admin dashboard.</a:t>
+            </a:r>
+          </a:p>
+          <a:p>
+            <a:pPr>
+              <a:spcAft>
+                <a:spcPts val="1400"/>
+              </a:spcAft>
+              <a:defRPr sz="1900">
+                <a:solidFill>
+                  <a:srgbClr val="323232"/>
+                </a:solidFill>
+              </a:defRPr>
+            </a:pPr>
+            <a:r>
+              <a:t>Real-time notifications.</a:t>
+            </a:r>
+          </a:p>
+          <a:p>
+            <a:pPr>
+              <a:spcAft>
+                <a:spcPts val="1400"/>
+              </a:spcAft>
+              <a:defRPr sz="1900">
+                <a:solidFill>
+                  <a:srgbClr val="323232"/>
+                </a:solidFill>
+              </a:defRPr>
+            </a:pPr>
+            <a:r>
+              <a:t>Hospital and blood-bank accounts.</a:t>
+            </a:r>
+          </a:p>
+          <a:p>
+            <a:pPr>
+              <a:spcAft>
+                <a:spcPts val="1400"/>
+              </a:spcAft>
+              <a:defRPr sz="1900">
+                <a:solidFill>
+                  <a:srgbClr val="323232"/>
+                </a:solidFill>
+              </a:defRPr>
+            </a:pPr>
+            <a:r>
+              <a:t>Secure user authentication.</a:t>
             </a:r>
           </a:p>
         </p:txBody>
@@ -9811,7 +9804,7 @@
               </a:defRPr>
             </a:pPr>
             <a:r>
-              <a:t>THANK YOU</a:t>
+              <a:t>CONCLUSION</a:t>
             </a:r>
           </a:p>
         </p:txBody>
@@ -9849,7 +9842,7 @@
               </a:defRPr>
             </a:pPr>
             <a:r>
-              <a:t>🩸 BLOOD BANKING SYSTEM</a:t>
+              <a:t>The Blood Banking System provides a simple way to manage blood donors, requests and inventory.</a:t>
             </a:r>
           </a:p>
           <a:p>
@@ -9864,6 +9857,136 @@
               </a:defRPr>
             </a:pPr>
             <a:r>
+              <a:t>HTML, CSS and JavaScript are used to build the system.</a:t>
+            </a:r>
+          </a:p>
+          <a:p>
+            <a:pPr>
+              <a:spcAft>
+                <a:spcPts val="1400"/>
+              </a:spcAft>
+              <a:defRPr sz="2200">
+                <a:solidFill>
+                  <a:srgbClr val="323232"/>
+                </a:solidFill>
+              </a:defRPr>
+            </a:pPr>
+            <a:r>
+              <a:t>The project demonstrates how a basic web application can support blood availability management.</a:t>
+            </a:r>
+          </a:p>
+        </p:txBody>
+      </p:sp>
+    </p:spTree>
+  </p:cSld>
+  <p:clrMapOvr>
+    <a:masterClrMapping/>
+  </p:clrMapOvr>
+</p:sld>
+</file>
+
+<file path=ppt/slides/slide15.xml><?xml version="1.0" encoding="utf-8"?>
+<p:sld xmlns:a="http://schemas.openxmlformats.org/drawingml/2006/main" xmlns:r="http://schemas.openxmlformats.org/officeDocument/2006/relationships" xmlns:p="http://schemas.openxmlformats.org/presentationml/2006/main">
+  <p:cSld>
+    <p:spTree>
+      <p:nvGrpSpPr>
+        <p:cNvPr id="1" name=""/>
+        <p:cNvGrpSpPr/>
+        <p:nvPr/>
+      </p:nvGrpSpPr>
+      <p:grpSpPr>
+        <a:xfrm>
+          <a:off x="0" y="0"/>
+          <a:ext cx="0" cy="0"/>
+          <a:chOff x="0" y="0"/>
+          <a:chExt cx="0" cy="0"/>
+        </a:xfrm>
+      </p:grpSpPr>
+      <p:sp>
+        <p:nvSpPr>
+          <p:cNvPr id="2" name="TextBox 1"/>
+          <p:cNvSpPr txBox="1"/>
+          <p:nvPr/>
+        </p:nvSpPr>
+        <p:spPr>
+          <a:xfrm>
+            <a:off x="640080" y="411480"/>
+            <a:ext cx="10972800" cy="731520"/>
+          </a:xfrm>
+          <a:prstGeom prst="rect">
+            <a:avLst/>
+          </a:prstGeom>
+          <a:noFill/>
+        </p:spPr>
+        <p:txBody>
+          <a:bodyPr wrap="none">
+            <a:spAutoFit/>
+          </a:bodyPr>
+          <a:lstStyle/>
+          <a:p>
+            <a:pPr>
+              <a:defRPr sz="3000" b="1">
+                <a:solidFill>
+                  <a:srgbClr val="B30000"/>
+                </a:solidFill>
+              </a:defRPr>
+            </a:pPr>
+            <a:r>
+              <a:t>THANK YOU</a:t>
+            </a:r>
+          </a:p>
+        </p:txBody>
+      </p:sp>
+      <p:sp>
+        <p:nvSpPr>
+          <p:cNvPr id="3" name="TextBox 2"/>
+          <p:cNvSpPr txBox="1"/>
+          <p:nvPr/>
+        </p:nvSpPr>
+        <p:spPr>
+          <a:xfrm>
+            <a:off x="822960" y="1371600"/>
+            <a:ext cx="10607040" cy="4754880"/>
+          </a:xfrm>
+          <a:prstGeom prst="rect">
+            <a:avLst/>
+          </a:prstGeom>
+          <a:noFill/>
+        </p:spPr>
+        <p:txBody>
+          <a:bodyPr wrap="square">
+            <a:spAutoFit/>
+          </a:bodyPr>
+          <a:lstStyle/>
+          <a:p>
+            <a:pPr>
+              <a:spcAft>
+                <a:spcPts val="1400"/>
+              </a:spcAft>
+              <a:defRPr sz="2200">
+                <a:solidFill>
+                  <a:srgbClr val="323232"/>
+                </a:solidFill>
+              </a:defRPr>
+            </a:pPr>
+            <a:r>
+              <a:rPr dirty="0"/>
+              <a:t>🩸 BLOOD BANKING SYSTEM</a:t>
+            </a:r>
+          </a:p>
+          <a:p>
+            <a:pPr>
+              <a:spcAft>
+                <a:spcPts val="1400"/>
+              </a:spcAft>
+              <a:defRPr sz="2200">
+                <a:solidFill>
+                  <a:srgbClr val="323232"/>
+                </a:solidFill>
+              </a:defRPr>
+            </a:pPr>
+            <a:r>
+              <a:rPr dirty="0"/>
               <a:t>Questions?</a:t>
             </a:r>
           </a:p>
@@ -9924,7 +10047,8 @@
               </a:defRPr>
             </a:pPr>
             <a:r>
-              <a:t>PROJECT OVERVIEW</a:t>
+              <a:rPr dirty="0"/>
+              <a:t>BLOOD BANKING SYSTEM</a:t>
             </a:r>
           </a:p>
         </p:txBody>
@@ -9938,7 +10062,7 @@
         <p:spPr>
           <a:xfrm>
             <a:off x="822960" y="1371600"/>
-            <a:ext cx="10607040" cy="4754880"/>
+            <a:ext cx="10607040" cy="2503249"/>
           </a:xfrm>
           <a:prstGeom prst="rect">
             <a:avLst/>
@@ -9962,7 +10086,8 @@
               </a:defRPr>
             </a:pPr>
             <a:r>
-              <a:t>The system connects blood donors with people who need blood.</a:t>
+              <a:rPr dirty="0"/>
+              <a:t>A simple web-based Blood Banking System</a:t>
             </a:r>
           </a:p>
           <a:p>
@@ -9977,7 +10102,8 @@
               </a:defRPr>
             </a:pPr>
             <a:r>
-              <a:t>Donors can register their blood group and location.</a:t>
+              <a:rPr dirty="0"/>
+              <a:t>Front End Development Frameworks Project</a:t>
             </a:r>
           </a:p>
           <a:p>
@@ -9992,8 +10118,10 @@
               </a:defRPr>
             </a:pPr>
             <a:r>
-              <a:t>Receivers can request required blood units.</a:t>
-            </a:r>
+              <a:rPr dirty="0"/>
+              <a:t>Donor Registration </a:t>
+            </a:r>
+            <a:endParaRPr lang="en-US" dirty="0"/>
           </a:p>
           <a:p>
             <a:pPr>
@@ -10007,7 +10135,25 @@
               </a:defRPr>
             </a:pPr>
             <a:r>
-              <a:t>The system maintains available blood inventory.</a:t>
+              <a:rPr dirty="0"/>
+              <a:t>• Blood Requests </a:t>
+            </a:r>
+            <a:endParaRPr lang="en-US" dirty="0"/>
+          </a:p>
+          <a:p>
+            <a:pPr>
+              <a:spcAft>
+                <a:spcPts val="1400"/>
+              </a:spcAft>
+              <a:defRPr sz="2200">
+                <a:solidFill>
+                  <a:srgbClr val="323232"/>
+                </a:solidFill>
+              </a:defRPr>
+            </a:pPr>
+            <a:r>
+              <a:rPr dirty="0"/>
+              <a:t>• Inventory Management</a:t>
             </a:r>
           </a:p>
         </p:txBody>
@@ -10067,7 +10213,7 @@
               </a:defRPr>
             </a:pPr>
             <a:r>
-              <a:t>PROBLEM STATEMENT</a:t>
+              <a:t>PROJECT OVERVIEW</a:t>
             </a:r>
           </a:p>
         </p:txBody>
@@ -10105,7 +10251,7 @@
               </a:defRPr>
             </a:pPr>
             <a:r>
-              <a:t>Finding required blood quickly can be difficult during emergencies.</a:t>
+              <a:t>The system connects blood donors with people who need blood.</a:t>
             </a:r>
           </a:p>
           <a:p>
@@ -10120,7 +10266,7 @@
               </a:defRPr>
             </a:pPr>
             <a:r>
-              <a:t>Manual blood records can be slow and difficult to maintain.</a:t>
+              <a:t>Donors can register their blood group and location.</a:t>
             </a:r>
           </a:p>
           <a:p>
@@ -10135,7 +10281,22 @@
               </a:defRPr>
             </a:pPr>
             <a:r>
-              <a:t>There is a need for a simple system to manage donors, requests and inventory.</a:t>
+              <a:t>Receivers can request required blood units.</a:t>
+            </a:r>
+          </a:p>
+          <a:p>
+            <a:pPr>
+              <a:spcAft>
+                <a:spcPts val="1400"/>
+              </a:spcAft>
+              <a:defRPr sz="2200">
+                <a:solidFill>
+                  <a:srgbClr val="323232"/>
+                </a:solidFill>
+              </a:defRPr>
+            </a:pPr>
+            <a:r>
+              <a:t>The system maintains available blood inventory.</a:t>
             </a:r>
           </a:p>
         </p:txBody>
@@ -10195,7 +10356,7 @@
               </a:defRPr>
             </a:pPr>
             <a:r>
-              <a:t>OBJECTIVES</a:t>
+              <a:t>PROBLEM STATEMENT</a:t>
             </a:r>
           </a:p>
         </p:txBody>
@@ -10226,14 +10387,14 @@
               <a:spcAft>
                 <a:spcPts val="1400"/>
               </a:spcAft>
-              <a:defRPr sz="1900">
+              <a:defRPr sz="2200">
                 <a:solidFill>
                   <a:srgbClr val="323232"/>
                 </a:solidFill>
               </a:defRPr>
             </a:pPr>
             <a:r>
-              <a:t>Register blood donors easily.</a:t>
+              <a:t>Finding required blood quickly can be difficult during emergencies.</a:t>
             </a:r>
           </a:p>
           <a:p>
@@ -10241,14 +10402,14 @@
               <a:spcAft>
                 <a:spcPts val="1400"/>
               </a:spcAft>
-              <a:defRPr sz="1900">
+              <a:defRPr sz="2200">
                 <a:solidFill>
                   <a:srgbClr val="323232"/>
                 </a:solidFill>
               </a:defRPr>
             </a:pPr>
             <a:r>
-              <a:t>Allow receivers to request blood.</a:t>
+              <a:t>Manual blood records can be slow and difficult to maintain.</a:t>
             </a:r>
           </a:p>
           <a:p>
@@ -10256,59 +10417,14 @@
               <a:spcAft>
                 <a:spcPts val="1400"/>
               </a:spcAft>
-              <a:defRPr sz="1900">
+              <a:defRPr sz="2200">
                 <a:solidFill>
                   <a:srgbClr val="323232"/>
                 </a:solidFill>
               </a:defRPr>
             </a:pPr>
             <a:r>
-              <a:t>Track blood group availability.</a:t>
-            </a:r>
-          </a:p>
-          <a:p>
-            <a:pPr>
-              <a:spcAft>
-                <a:spcPts val="1400"/>
-              </a:spcAft>
-              <a:defRPr sz="1900">
-                <a:solidFill>
-                  <a:srgbClr val="323232"/>
-                </a:solidFill>
-              </a:defRPr>
-            </a:pPr>
-            <a:r>
-              <a:t>Increase inventory when a donor registers.</a:t>
-            </a:r>
-          </a:p>
-          <a:p>
-            <a:pPr>
-              <a:spcAft>
-                <a:spcPts val="1400"/>
-              </a:spcAft>
-              <a:defRPr sz="1900">
-                <a:solidFill>
-                  <a:srgbClr val="323232"/>
-                </a:solidFill>
-              </a:defRPr>
-            </a:pPr>
-            <a:r>
-              <a:t>Decrease inventory when a valid blood request is made.</a:t>
-            </a:r>
-          </a:p>
-          <a:p>
-            <a:pPr>
-              <a:spcAft>
-                <a:spcPts val="1400"/>
-              </a:spcAft>
-              <a:defRPr sz="1900">
-                <a:solidFill>
-                  <a:srgbClr val="323232"/>
-                </a:solidFill>
-              </a:defRPr>
-            </a:pPr>
-            <a:r>
-              <a:t>Support location-based matching using state and city.</a:t>
+              <a:t>There is a need for a simple system to manage donors, requests and inventory.</a:t>
             </a:r>
           </a:p>
         </p:txBody>
@@ -10368,7 +10484,7 @@
               </a:defRPr>
             </a:pPr>
             <a:r>
-              <a:t>TECHNOLOGIES USED</a:t>
+              <a:t>OBJECTIVES</a:t>
             </a:r>
           </a:p>
         </p:txBody>
@@ -10399,14 +10515,14 @@
               <a:spcAft>
                 <a:spcPts val="1400"/>
               </a:spcAft>
-              <a:defRPr sz="2200">
+              <a:defRPr sz="1900">
                 <a:solidFill>
                   <a:srgbClr val="323232"/>
                 </a:solidFill>
               </a:defRPr>
             </a:pPr>
             <a:r>
-              <a:t>HTML – structure of web pages</a:t>
+              <a:t>Register blood donors easily.</a:t>
             </a:r>
           </a:p>
           <a:p>
@@ -10414,14 +10530,14 @@
               <a:spcAft>
                 <a:spcPts val="1400"/>
               </a:spcAft>
-              <a:defRPr sz="2200">
+              <a:defRPr sz="1900">
                 <a:solidFill>
                   <a:srgbClr val="323232"/>
                 </a:solidFill>
               </a:defRPr>
             </a:pPr>
             <a:r>
-              <a:t>CSS – page design and styling</a:t>
+              <a:t>Allow receivers to request blood.</a:t>
             </a:r>
           </a:p>
           <a:p>
@@ -10429,14 +10545,14 @@
               <a:spcAft>
                 <a:spcPts val="1400"/>
               </a:spcAft>
-              <a:defRPr sz="2200">
+              <a:defRPr sz="1900">
                 <a:solidFill>
                   <a:srgbClr val="323232"/>
                 </a:solidFill>
               </a:defRPr>
             </a:pPr>
             <a:r>
-              <a:t>JavaScript – system logic and interactions</a:t>
+              <a:t>Track blood group availability.</a:t>
             </a:r>
           </a:p>
           <a:p>
@@ -10444,14 +10560,44 @@
               <a:spcAft>
                 <a:spcPts val="1400"/>
               </a:spcAft>
-              <a:defRPr sz="2200">
+              <a:defRPr sz="1900">
                 <a:solidFill>
                   <a:srgbClr val="323232"/>
                 </a:solidFill>
               </a:defRPr>
             </a:pPr>
             <a:r>
-              <a:t>LocalStorage – storing inventory and project data in the browser</a:t>
+              <a:t>Increase inventory when a donor registers.</a:t>
+            </a:r>
+          </a:p>
+          <a:p>
+            <a:pPr>
+              <a:spcAft>
+                <a:spcPts val="1400"/>
+              </a:spcAft>
+              <a:defRPr sz="1900">
+                <a:solidFill>
+                  <a:srgbClr val="323232"/>
+                </a:solidFill>
+              </a:defRPr>
+            </a:pPr>
+            <a:r>
+              <a:t>Decrease inventory when a valid blood request is made.</a:t>
+            </a:r>
+          </a:p>
+          <a:p>
+            <a:pPr>
+              <a:spcAft>
+                <a:spcPts val="1400"/>
+              </a:spcAft>
+              <a:defRPr sz="1900">
+                <a:solidFill>
+                  <a:srgbClr val="323232"/>
+                </a:solidFill>
+              </a:defRPr>
+            </a:pPr>
+            <a:r>
+              <a:t>Support location-based matching using state and city.</a:t>
             </a:r>
           </a:p>
         </p:txBody>
@@ -10511,7 +10657,7 @@
               </a:defRPr>
             </a:pPr>
             <a:r>
-              <a:t>MODULES</a:t>
+              <a:t>TECHNOLOGIES USED</a:t>
             </a:r>
           </a:p>
         </p:txBody>
@@ -10542,14 +10688,14 @@
               <a:spcAft>
                 <a:spcPts val="1400"/>
               </a:spcAft>
-              <a:defRPr sz="1900">
+              <a:defRPr sz="2200">
                 <a:solidFill>
                   <a:srgbClr val="323232"/>
                 </a:solidFill>
               </a:defRPr>
             </a:pPr>
             <a:r>
-              <a:t>1. Login Page – selects Donor or Receiver.</a:t>
+              <a:t>HTML – structure of web pages</a:t>
             </a:r>
           </a:p>
           <a:p>
@@ -10557,14 +10703,14 @@
               <a:spcAft>
                 <a:spcPts val="1400"/>
               </a:spcAft>
-              <a:defRPr sz="1900">
+              <a:defRPr sz="2200">
                 <a:solidFill>
                   <a:srgbClr val="323232"/>
                 </a:solidFill>
               </a:defRPr>
             </a:pPr>
             <a:r>
-              <a:t>2. Donor Registration – collects donor details.</a:t>
+              <a:t>CSS – page design and styling</a:t>
             </a:r>
           </a:p>
           <a:p>
@@ -10572,14 +10718,14 @@
               <a:spcAft>
                 <a:spcPts val="1400"/>
               </a:spcAft>
-              <a:defRPr sz="1900">
+              <a:defRPr sz="2200">
                 <a:solidFill>
                   <a:srgbClr val="323232"/>
                 </a:solidFill>
               </a:defRPr>
             </a:pPr>
             <a:r>
-              <a:t>3. Receiver Request – collects blood request details.</a:t>
+              <a:t>JavaScript – system logic and interactions</a:t>
             </a:r>
           </a:p>
           <a:p>
@@ -10587,29 +10733,14 @@
               <a:spcAft>
                 <a:spcPts val="1400"/>
               </a:spcAft>
-              <a:defRPr sz="1900">
+              <a:defRPr sz="2200">
                 <a:solidFill>
                   <a:srgbClr val="323232"/>
                 </a:solidFill>
               </a:defRPr>
             </a:pPr>
             <a:r>
-              <a:t>4. Blood Inventory – displays available units for each blood group.</a:t>
-            </a:r>
-          </a:p>
-          <a:p>
-            <a:pPr>
-              <a:spcAft>
-                <a:spcPts val="1400"/>
-              </a:spcAft>
-              <a:defRPr sz="1900">
-                <a:solidFill>
-                  <a:srgbClr val="323232"/>
-                </a:solidFill>
-              </a:defRPr>
-            </a:pPr>
-            <a:r>
-              <a:t>5. About / Contact – project information and contact details.</a:t>
+              <a:t>LocalStorage – storing inventory and project data in the browser</a:t>
             </a:r>
           </a:p>
         </p:txBody>
@@ -10669,7 +10800,7 @@
               </a:defRPr>
             </a:pPr>
             <a:r>
-              <a:t>DONOR REGISTRATION</a:t>
+              <a:t>MODULES</a:t>
             </a:r>
           </a:p>
         </p:txBody>
@@ -10700,14 +10831,14 @@
               <a:spcAft>
                 <a:spcPts val="1400"/>
               </a:spcAft>
-              <a:defRPr sz="2200">
+              <a:defRPr sz="1900">
                 <a:solidFill>
                   <a:srgbClr val="323232"/>
                 </a:solidFill>
               </a:defRPr>
             </a:pPr>
             <a:r>
-              <a:t>Donor enters name, age, gender, blood group, state, city and phone number.</a:t>
+              <a:t>1. Login Page – selects Donor or Receiver.</a:t>
             </a:r>
           </a:p>
           <a:p>
@@ -10715,14 +10846,14 @@
               <a:spcAft>
                 <a:spcPts val="1400"/>
               </a:spcAft>
-              <a:defRPr sz="2200">
+              <a:defRPr sz="1900">
                 <a:solidFill>
                   <a:srgbClr val="323232"/>
                 </a:solidFill>
               </a:defRPr>
             </a:pPr>
             <a:r>
-              <a:t>After registration, the selected blood group is added to inventory.</a:t>
+              <a:t>2. Donor Registration – collects donor details.</a:t>
             </a:r>
           </a:p>
           <a:p>
@@ -10730,14 +10861,44 @@
               <a:spcAft>
                 <a:spcPts val="1400"/>
               </a:spcAft>
-              <a:defRPr sz="2200">
+              <a:defRPr sz="1900">
                 <a:solidFill>
                   <a:srgbClr val="323232"/>
                 </a:solidFill>
               </a:defRPr>
             </a:pPr>
             <a:r>
-              <a:t>The donor is redirected to the Blood Inventory page.</a:t>
+              <a:t>3. Receiver Request – collects blood request details.</a:t>
+            </a:r>
+          </a:p>
+          <a:p>
+            <a:pPr>
+              <a:spcAft>
+                <a:spcPts val="1400"/>
+              </a:spcAft>
+              <a:defRPr sz="1900">
+                <a:solidFill>
+                  <a:srgbClr val="323232"/>
+                </a:solidFill>
+              </a:defRPr>
+            </a:pPr>
+            <a:r>
+              <a:t>4. Blood Inventory – displays available units for each blood group.</a:t>
+            </a:r>
+          </a:p>
+          <a:p>
+            <a:pPr>
+              <a:spcAft>
+                <a:spcPts val="1400"/>
+              </a:spcAft>
+              <a:defRPr sz="1900">
+                <a:solidFill>
+                  <a:srgbClr val="323232"/>
+                </a:solidFill>
+              </a:defRPr>
+            </a:pPr>
+            <a:r>
+              <a:t>5. About / Contact – project information and contact details.</a:t>
             </a:r>
           </a:p>
         </p:txBody>
@@ -10797,7 +10958,7 @@
               </a:defRPr>
             </a:pPr>
             <a:r>
-              <a:t>BLOOD REQUEST</a:t>
+              <a:t>DONOR REGISTRATION</a:t>
             </a:r>
           </a:p>
         </p:txBody>
@@ -10828,14 +10989,14 @@
               <a:spcAft>
                 <a:spcPts val="1400"/>
               </a:spcAft>
-              <a:defRPr sz="1900">
+              <a:defRPr sz="2200">
                 <a:solidFill>
                   <a:srgbClr val="323232"/>
                 </a:solidFill>
               </a:defRPr>
             </a:pPr>
             <a:r>
-              <a:t>Receiver enters patient and hospital details.</a:t>
+              <a:t>Donor enters name, age, gender, blood group, state, city and phone number.</a:t>
             </a:r>
           </a:p>
           <a:p>
@@ -10843,14 +11004,14 @@
               <a:spcAft>
                 <a:spcPts val="1400"/>
               </a:spcAft>
-              <a:defRPr sz="1900">
+              <a:defRPr sz="2200">
                 <a:solidFill>
                   <a:srgbClr val="323232"/>
                 </a:solidFill>
               </a:defRPr>
             </a:pPr>
             <a:r>
-              <a:t>Receiver selects the required blood group and number of units.</a:t>
+              <a:t>After registration, the selected blood group is added to inventory.</a:t>
             </a:r>
           </a:p>
           <a:p>
@@ -10858,44 +11019,14 @@
               <a:spcAft>
                 <a:spcPts val="1400"/>
               </a:spcAft>
-              <a:defRPr sz="1900">
+              <a:defRPr sz="2200">
                 <a:solidFill>
                   <a:srgbClr val="323232"/>
                 </a:solidFill>
               </a:defRPr>
             </a:pPr>
             <a:r>
-              <a:t>The system checks the available inventory.</a:t>
-            </a:r>
-          </a:p>
-          <a:p>
-            <a:pPr>
-              <a:spcAft>
-                <a:spcPts val="1400"/>
-              </a:spcAft>
-              <a:defRPr sz="1900">
-                <a:solidFill>
-                  <a:srgbClr val="323232"/>
-                </a:solidFill>
-              </a:defRPr>
-            </a:pPr>
-            <a:r>
-              <a:t>If enough blood is available, the requested units are deducted.</a:t>
-            </a:r>
-          </a:p>
-          <a:p>
-            <a:pPr>
-              <a:spcAft>
-                <a:spcPts val="1400"/>
-              </a:spcAft>
-              <a:defRPr sz="1900">
-                <a:solidFill>
-                  <a:srgbClr val="323232"/>
-                </a:solidFill>
-              </a:defRPr>
-            </a:pPr>
-            <a:r>
-              <a:t>If blood is not available, the system displays an alert.</a:t>
+              <a:t>The donor is redirected to the Blood Inventory page.</a:t>
             </a:r>
           </a:p>
         </p:txBody>
@@ -10955,7 +11086,7 @@
               </a:defRPr>
             </a:pPr>
             <a:r>
-              <a:t>BLOOD INVENTORY</a:t>
+              <a:t>BLOOD REQUEST</a:t>
             </a:r>
           </a:p>
         </p:txBody>
@@ -10986,14 +11117,14 @@
               <a:spcAft>
                 <a:spcPts val="1400"/>
               </a:spcAft>
-              <a:defRPr sz="2200">
+              <a:defRPr sz="1900">
                 <a:solidFill>
                   <a:srgbClr val="323232"/>
                 </a:solidFill>
               </a:defRPr>
             </a:pPr>
             <a:r>
-              <a:t>Displays all 8 blood groups:</a:t>
+              <a:t>Receiver enters patient and hospital details.</a:t>
             </a:r>
           </a:p>
           <a:p>
@@ -11001,14 +11132,14 @@
               <a:spcAft>
                 <a:spcPts val="1400"/>
               </a:spcAft>
-              <a:defRPr sz="2200">
+              <a:defRPr sz="1900">
                 <a:solidFill>
                   <a:srgbClr val="323232"/>
                 </a:solidFill>
               </a:defRPr>
             </a:pPr>
             <a:r>
-              <a:t>A+, A-, B+, B-, AB+, AB-, O+, O-</a:t>
+              <a:t>Receiver selects the required blood group and number of units.</a:t>
             </a:r>
           </a:p>
           <a:p>
@@ -11016,14 +11147,14 @@
               <a:spcAft>
                 <a:spcPts val="1400"/>
               </a:spcAft>
-              <a:defRPr sz="2200">
+              <a:defRPr sz="1900">
                 <a:solidFill>
                   <a:srgbClr val="323232"/>
                 </a:solidFill>
               </a:defRPr>
             </a:pPr>
             <a:r>
-              <a:t>Inventory starts from 0.</a:t>
+              <a:t>The system checks the available inventory.</a:t>
             </a:r>
           </a:p>
           <a:p>
@@ -11031,14 +11162,29 @@
               <a:spcAft>
                 <a:spcPts val="1400"/>
               </a:spcAft>
-              <a:defRPr sz="2200">
+              <a:defRPr sz="1900">
                 <a:solidFill>
                   <a:srgbClr val="323232"/>
                 </a:solidFill>
               </a:defRPr>
             </a:pPr>
             <a:r>
-              <a:t>Values are updated automatically using donor registrations and blood requests.</a:t>
+              <a:t>If enough blood is available, the requested units are deducted.</a:t>
+            </a:r>
+          </a:p>
+          <a:p>
+            <a:pPr>
+              <a:spcAft>
+                <a:spcPts val="1400"/>
+              </a:spcAft>
+              <a:defRPr sz="1900">
+                <a:solidFill>
+                  <a:srgbClr val="323232"/>
+                </a:solidFill>
+              </a:defRPr>
+            </a:pPr>
+            <a:r>
+              <a:t>If blood is not available, the system displays an alert.</a:t>
             </a:r>
           </a:p>
         </p:txBody>

</xml_diff>